<commit_message>
Backlog slide: call out the two pending stages
The 657 open figure includes Pending Internal and Pending External.
That was never visible on the slide, so anyone reading it had to take
the definition on trust.

Adds a stage strip under the AI summary — New / In Progress / Pending
Internal / Pending External — with the two pending states picked out in
gold, and a note giving the figure both ways: 41 tickets, 6% of the
backlog, 616 without them. The strip is data-driven (backlog.stages),
so the slide falls back to the old full-height summary when a week's
data file does not carry it.

The note also puts the sharper number on the slide: 529 of 657, 81%,
have never left New.

Co-Authored-By: Claude Opus 5 <noreply@anthropic.com>
Claude-Session: https://claude.ai/code/session_019YTPNjRj34XzLPLC9gKxc4
</commit_message>
<xml_diff>
--- a/exec-deck/output/H&L Weekly Update - WC 5 Oct 2026.pptx
+++ b/exec-deck/output/H&L Weekly Update - WC 5 Oct 2026.pptx
@@ -53406,11 +53406,11 @@
         <p:spPr>
           <a:xfrm>
             <a:off x="7178040" y="2395728"/>
-            <a:ext cx="4599432" cy="3913632"/>
+            <a:ext cx="4599432" cy="2788920"/>
           </a:xfrm>
           <a:prstGeom prst="roundRect">
             <a:avLst>
-              <a:gd name="adj" fmla="val 1636"/>
+              <a:gd name="adj" fmla="val 2295"/>
             </a:avLst>
           </a:prstGeom>
           <a:solidFill>
@@ -53474,7 +53474,7 @@
         <p:spPr>
           <a:xfrm>
             <a:off x="7379208" y="2816352"/>
-            <a:ext cx="4187952" cy="3364992"/>
+            <a:ext cx="4187952" cy="2240280"/>
           </a:xfrm>
           <a:prstGeom prst="rect">
             <a:avLst/>
@@ -53673,6 +53673,559 @@
         </p:nvSpPr>
         <p:spPr>
           <a:xfrm>
+            <a:off x="7178040" y="5303520"/>
+            <a:ext cx="4599432" cy="1005840"/>
+          </a:xfrm>
+          <a:prstGeom prst="roundRect">
+            <a:avLst>
+              <a:gd name="adj" fmla="val 6364"/>
+            </a:avLst>
+          </a:prstGeom>
+          <a:solidFill>
+            <a:srgbClr val="FFFFFF"/>
+          </a:solidFill>
+          <a:ln/>
+          <a:effectLst>
+            <a:outerShdw sx="100000" sy="100000" kx="0" ky="0" algn="bl" rotWithShape="0" blurRad="76200" dist="25400" dir="5400000">
+              <a:srgbClr val="9AAAB5">
+                <a:alpha val="35000"/>
+              </a:srgbClr>
+            </a:outerShdw>
+          </a:effectLst>
+        </p:spPr>
+      </p:sp>
+      <p:sp>
+        <p:nvSpPr>
+          <p:cNvPr id="176" name="Text 174"/>
+          <p:cNvSpPr txBox="1"/>
+          <p:nvPr/>
+        </p:nvSpPr>
+        <p:spPr>
+          <a:xfrm>
+            <a:off x="7379208" y="5394960"/>
+            <a:ext cx="4197096" cy="201168"/>
+          </a:xfrm>
+          <a:prstGeom prst="rect">
+            <a:avLst/>
+          </a:prstGeom>
+          <a:noFill/>
+          <a:ln/>
+        </p:spPr>
+        <p:txBody>
+          <a:bodyPr wrap="square" lIns="0" tIns="0" rIns="0" bIns="0" rtlCol="0" anchor="ctr"/>
+          <a:lstStyle/>
+          <a:p>
+            <a:pPr indent="0" marL="0">
+              <a:buNone/>
+            </a:pPr>
+            <a:r>
+              <a:rPr lang="en-US" sz="950" b="1" dirty="0">
+                <a:solidFill>
+                  <a:srgbClr val="2C8394"/>
+                </a:solidFill>
+                <a:latin typeface="Poppins" pitchFamily="34" charset="0"/>
+                <a:ea typeface="Poppins" pitchFamily="34" charset="-122"/>
+                <a:cs typeface="Poppins" pitchFamily="34" charset="-120"/>
+              </a:rPr>
+              <a:t>WHERE THE 657 OPEN SIT   </a:t>
+            </a:r>
+            <a:pPr indent="0" marL="0">
+              <a:buNone/>
+            </a:pPr>
+            <a:r>
+              <a:rPr lang="en-US" sz="630" dirty="0">
+                <a:solidFill>
+                  <a:srgbClr val="8FA1AC"/>
+                </a:solidFill>
+                <a:latin typeface="Poppins" pitchFamily="34" charset="0"/>
+                <a:ea typeface="Poppins" pitchFamily="34" charset="-122"/>
+                <a:cs typeface="Poppins" pitchFamily="34" charset="-120"/>
+              </a:rPr>
+              <a:t>the two pending states are counted in</a:t>
+            </a:r>
+            <a:endParaRPr lang="en-US" sz="950" dirty="0"/>
+          </a:p>
+        </p:txBody>
+      </p:sp>
+      <p:sp>
+        <p:nvSpPr>
+          <p:cNvPr id="177" name="Shape 175"/>
+          <p:cNvSpPr/>
+          <p:nvPr/>
+        </p:nvSpPr>
+        <p:spPr>
+          <a:xfrm>
+            <a:off x="7379208" y="5632704"/>
+            <a:ext cx="1001268" cy="420624"/>
+          </a:xfrm>
+          <a:prstGeom prst="rect">
+            <a:avLst/>
+          </a:prstGeom>
+          <a:solidFill>
+            <a:srgbClr val="F2F6F8"/>
+          </a:solidFill>
+          <a:ln/>
+        </p:spPr>
+      </p:sp>
+      <p:sp>
+        <p:nvSpPr>
+          <p:cNvPr id="178" name="Text 176"/>
+          <p:cNvSpPr txBox="1"/>
+          <p:nvPr/>
+        </p:nvSpPr>
+        <p:spPr>
+          <a:xfrm>
+            <a:off x="7470648" y="5660136"/>
+            <a:ext cx="818388" cy="219456"/>
+          </a:xfrm>
+          <a:prstGeom prst="rect">
+            <a:avLst/>
+          </a:prstGeom>
+          <a:noFill/>
+          <a:ln/>
+        </p:spPr>
+        <p:txBody>
+          <a:bodyPr wrap="square" lIns="0" tIns="0" rIns="0" bIns="0" rtlCol="0" anchor="ctr"/>
+          <a:lstStyle/>
+          <a:p>
+            <a:pPr algn="ctr" indent="0" marL="0">
+              <a:buNone/>
+            </a:pPr>
+            <a:r>
+              <a:rPr lang="en-US" sz="1400" b="1" dirty="0">
+                <a:solidFill>
+                  <a:srgbClr val="12293A"/>
+                </a:solidFill>
+                <a:latin typeface="Poppins" pitchFamily="34" charset="0"/>
+                <a:ea typeface="Poppins" pitchFamily="34" charset="-122"/>
+                <a:cs typeface="Poppins" pitchFamily="34" charset="-120"/>
+              </a:rPr>
+              <a:t>529</a:t>
+            </a:r>
+            <a:endParaRPr lang="en-US" sz="1400" dirty="0"/>
+          </a:p>
+        </p:txBody>
+      </p:sp>
+      <p:sp>
+        <p:nvSpPr>
+          <p:cNvPr id="179" name="Text 177"/>
+          <p:cNvSpPr txBox="1"/>
+          <p:nvPr/>
+        </p:nvSpPr>
+        <p:spPr>
+          <a:xfrm>
+            <a:off x="7406640" y="5879592"/>
+            <a:ext cx="946404" cy="155448"/>
+          </a:xfrm>
+          <a:prstGeom prst="rect">
+            <a:avLst/>
+          </a:prstGeom>
+          <a:noFill/>
+          <a:ln/>
+        </p:spPr>
+        <p:txBody>
+          <a:bodyPr wrap="square" lIns="0" tIns="0" rIns="0" bIns="0" rtlCol="0" anchor="ctr"/>
+          <a:lstStyle/>
+          <a:p>
+            <a:pPr algn="ctr" indent="0" marL="0">
+              <a:buNone/>
+            </a:pPr>
+            <a:r>
+              <a:rPr lang="en-US" sz="620" b="1" dirty="0">
+                <a:solidFill>
+                  <a:srgbClr val="5E7280"/>
+                </a:solidFill>
+                <a:latin typeface="Poppins" pitchFamily="34" charset="0"/>
+                <a:ea typeface="Poppins" pitchFamily="34" charset="-122"/>
+                <a:cs typeface="Poppins" pitchFamily="34" charset="-120"/>
+              </a:rPr>
+              <a:t>NEW</a:t>
+            </a:r>
+            <a:endParaRPr lang="en-US" sz="620" dirty="0"/>
+          </a:p>
+        </p:txBody>
+      </p:sp>
+      <p:sp>
+        <p:nvSpPr>
+          <p:cNvPr id="180" name="Shape 178"/>
+          <p:cNvSpPr/>
+          <p:nvPr/>
+        </p:nvSpPr>
+        <p:spPr>
+          <a:xfrm>
+            <a:off x="8444484" y="5632704"/>
+            <a:ext cx="1001268" cy="420624"/>
+          </a:xfrm>
+          <a:prstGeom prst="rect">
+            <a:avLst/>
+          </a:prstGeom>
+          <a:solidFill>
+            <a:srgbClr val="F2F6F8"/>
+          </a:solidFill>
+          <a:ln/>
+        </p:spPr>
+      </p:sp>
+      <p:sp>
+        <p:nvSpPr>
+          <p:cNvPr id="181" name="Text 179"/>
+          <p:cNvSpPr txBox="1"/>
+          <p:nvPr/>
+        </p:nvSpPr>
+        <p:spPr>
+          <a:xfrm>
+            <a:off x="8535924" y="5660136"/>
+            <a:ext cx="818388" cy="219456"/>
+          </a:xfrm>
+          <a:prstGeom prst="rect">
+            <a:avLst/>
+          </a:prstGeom>
+          <a:noFill/>
+          <a:ln/>
+        </p:spPr>
+        <p:txBody>
+          <a:bodyPr wrap="square" lIns="0" tIns="0" rIns="0" bIns="0" rtlCol="0" anchor="ctr"/>
+          <a:lstStyle/>
+          <a:p>
+            <a:pPr algn="ctr" indent="0" marL="0">
+              <a:buNone/>
+            </a:pPr>
+            <a:r>
+              <a:rPr lang="en-US" sz="1400" b="1" dirty="0">
+                <a:solidFill>
+                  <a:srgbClr val="12293A"/>
+                </a:solidFill>
+                <a:latin typeface="Poppins" pitchFamily="34" charset="0"/>
+                <a:ea typeface="Poppins" pitchFamily="34" charset="-122"/>
+                <a:cs typeface="Poppins" pitchFamily="34" charset="-120"/>
+              </a:rPr>
+              <a:t>88</a:t>
+            </a:r>
+            <a:endParaRPr lang="en-US" sz="1400" dirty="0"/>
+          </a:p>
+        </p:txBody>
+      </p:sp>
+      <p:sp>
+        <p:nvSpPr>
+          <p:cNvPr id="182" name="Text 180"/>
+          <p:cNvSpPr txBox="1"/>
+          <p:nvPr/>
+        </p:nvSpPr>
+        <p:spPr>
+          <a:xfrm>
+            <a:off x="8471916" y="5879592"/>
+            <a:ext cx="946404" cy="155448"/>
+          </a:xfrm>
+          <a:prstGeom prst="rect">
+            <a:avLst/>
+          </a:prstGeom>
+          <a:noFill/>
+          <a:ln/>
+        </p:spPr>
+        <p:txBody>
+          <a:bodyPr wrap="square" lIns="0" tIns="0" rIns="0" bIns="0" rtlCol="0" anchor="ctr"/>
+          <a:lstStyle/>
+          <a:p>
+            <a:pPr algn="ctr" indent="0" marL="0">
+              <a:buNone/>
+            </a:pPr>
+            <a:r>
+              <a:rPr lang="en-US" sz="620" b="1" dirty="0">
+                <a:solidFill>
+                  <a:srgbClr val="5E7280"/>
+                </a:solidFill>
+                <a:latin typeface="Poppins" pitchFamily="34" charset="0"/>
+                <a:ea typeface="Poppins" pitchFamily="34" charset="-122"/>
+                <a:cs typeface="Poppins" pitchFamily="34" charset="-120"/>
+              </a:rPr>
+              <a:t>IN PROGRESS</a:t>
+            </a:r>
+            <a:endParaRPr lang="en-US" sz="620" dirty="0"/>
+          </a:p>
+        </p:txBody>
+      </p:sp>
+      <p:sp>
+        <p:nvSpPr>
+          <p:cNvPr id="183" name="Shape 181"/>
+          <p:cNvSpPr/>
+          <p:nvPr/>
+        </p:nvSpPr>
+        <p:spPr>
+          <a:xfrm>
+            <a:off x="9509760" y="5632704"/>
+            <a:ext cx="1001268" cy="420624"/>
+          </a:xfrm>
+          <a:prstGeom prst="rect">
+            <a:avLst/>
+          </a:prstGeom>
+          <a:solidFill>
+            <a:srgbClr val="F7EEDF"/>
+          </a:solidFill>
+          <a:ln/>
+        </p:spPr>
+      </p:sp>
+      <p:sp>
+        <p:nvSpPr>
+          <p:cNvPr id="184" name="Shape 182"/>
+          <p:cNvSpPr/>
+          <p:nvPr/>
+        </p:nvSpPr>
+        <p:spPr>
+          <a:xfrm>
+            <a:off x="9509760" y="5632704"/>
+            <a:ext cx="32004" cy="420624"/>
+          </a:xfrm>
+          <a:prstGeom prst="rect">
+            <a:avLst/>
+          </a:prstGeom>
+          <a:solidFill>
+            <a:srgbClr val="C88A2E"/>
+          </a:solidFill>
+          <a:ln/>
+        </p:spPr>
+      </p:sp>
+      <p:sp>
+        <p:nvSpPr>
+          <p:cNvPr id="185" name="Text 183"/>
+          <p:cNvSpPr txBox="1"/>
+          <p:nvPr/>
+        </p:nvSpPr>
+        <p:spPr>
+          <a:xfrm>
+            <a:off x="9601200" y="5660136"/>
+            <a:ext cx="818388" cy="219456"/>
+          </a:xfrm>
+          <a:prstGeom prst="rect">
+            <a:avLst/>
+          </a:prstGeom>
+          <a:noFill/>
+          <a:ln/>
+        </p:spPr>
+        <p:txBody>
+          <a:bodyPr wrap="square" lIns="0" tIns="0" rIns="0" bIns="0" rtlCol="0" anchor="ctr"/>
+          <a:lstStyle/>
+          <a:p>
+            <a:pPr algn="ctr" indent="0" marL="0">
+              <a:buNone/>
+            </a:pPr>
+            <a:r>
+              <a:rPr lang="en-US" sz="1400" b="1" dirty="0">
+                <a:solidFill>
+                  <a:srgbClr val="C88A2E"/>
+                </a:solidFill>
+                <a:latin typeface="Poppins" pitchFamily="34" charset="0"/>
+                <a:ea typeface="Poppins" pitchFamily="34" charset="-122"/>
+                <a:cs typeface="Poppins" pitchFamily="34" charset="-120"/>
+              </a:rPr>
+              <a:t>23</a:t>
+            </a:r>
+            <a:endParaRPr lang="en-US" sz="1400" dirty="0"/>
+          </a:p>
+        </p:txBody>
+      </p:sp>
+      <p:sp>
+        <p:nvSpPr>
+          <p:cNvPr id="186" name="Text 184"/>
+          <p:cNvSpPr txBox="1"/>
+          <p:nvPr/>
+        </p:nvSpPr>
+        <p:spPr>
+          <a:xfrm>
+            <a:off x="9537192" y="5879592"/>
+            <a:ext cx="946404" cy="155448"/>
+          </a:xfrm>
+          <a:prstGeom prst="rect">
+            <a:avLst/>
+          </a:prstGeom>
+          <a:noFill/>
+          <a:ln/>
+        </p:spPr>
+        <p:txBody>
+          <a:bodyPr wrap="square" lIns="0" tIns="0" rIns="0" bIns="0" rtlCol="0" anchor="ctr"/>
+          <a:lstStyle/>
+          <a:p>
+            <a:pPr algn="ctr" indent="0" marL="0">
+              <a:buNone/>
+            </a:pPr>
+            <a:r>
+              <a:rPr lang="en-US" sz="540" b="1" dirty="0">
+                <a:solidFill>
+                  <a:srgbClr val="C88A2E"/>
+                </a:solidFill>
+                <a:latin typeface="Poppins" pitchFamily="34" charset="0"/>
+                <a:ea typeface="Poppins" pitchFamily="34" charset="-122"/>
+                <a:cs typeface="Poppins" pitchFamily="34" charset="-120"/>
+              </a:rPr>
+              <a:t>PENDING INTERNAL</a:t>
+            </a:r>
+            <a:endParaRPr lang="en-US" sz="540" dirty="0"/>
+          </a:p>
+        </p:txBody>
+      </p:sp>
+      <p:sp>
+        <p:nvSpPr>
+          <p:cNvPr id="187" name="Shape 185"/>
+          <p:cNvSpPr/>
+          <p:nvPr/>
+        </p:nvSpPr>
+        <p:spPr>
+          <a:xfrm>
+            <a:off x="10575036" y="5632704"/>
+            <a:ext cx="1001268" cy="420624"/>
+          </a:xfrm>
+          <a:prstGeom prst="rect">
+            <a:avLst/>
+          </a:prstGeom>
+          <a:solidFill>
+            <a:srgbClr val="F7EEDF"/>
+          </a:solidFill>
+          <a:ln/>
+        </p:spPr>
+      </p:sp>
+      <p:sp>
+        <p:nvSpPr>
+          <p:cNvPr id="188" name="Shape 186"/>
+          <p:cNvSpPr/>
+          <p:nvPr/>
+        </p:nvSpPr>
+        <p:spPr>
+          <a:xfrm>
+            <a:off x="10575036" y="5632704"/>
+            <a:ext cx="32004" cy="420624"/>
+          </a:xfrm>
+          <a:prstGeom prst="rect">
+            <a:avLst/>
+          </a:prstGeom>
+          <a:solidFill>
+            <a:srgbClr val="C88A2E"/>
+          </a:solidFill>
+          <a:ln/>
+        </p:spPr>
+      </p:sp>
+      <p:sp>
+        <p:nvSpPr>
+          <p:cNvPr id="189" name="Text 187"/>
+          <p:cNvSpPr txBox="1"/>
+          <p:nvPr/>
+        </p:nvSpPr>
+        <p:spPr>
+          <a:xfrm>
+            <a:off x="10666476" y="5660136"/>
+            <a:ext cx="818388" cy="219456"/>
+          </a:xfrm>
+          <a:prstGeom prst="rect">
+            <a:avLst/>
+          </a:prstGeom>
+          <a:noFill/>
+          <a:ln/>
+        </p:spPr>
+        <p:txBody>
+          <a:bodyPr wrap="square" lIns="0" tIns="0" rIns="0" bIns="0" rtlCol="0" anchor="ctr"/>
+          <a:lstStyle/>
+          <a:p>
+            <a:pPr algn="ctr" indent="0" marL="0">
+              <a:buNone/>
+            </a:pPr>
+            <a:r>
+              <a:rPr lang="en-US" sz="1400" b="1" dirty="0">
+                <a:solidFill>
+                  <a:srgbClr val="C88A2E"/>
+                </a:solidFill>
+                <a:latin typeface="Poppins" pitchFamily="34" charset="0"/>
+                <a:ea typeface="Poppins" pitchFamily="34" charset="-122"/>
+                <a:cs typeface="Poppins" pitchFamily="34" charset="-120"/>
+              </a:rPr>
+              <a:t>18</a:t>
+            </a:r>
+            <a:endParaRPr lang="en-US" sz="1400" dirty="0"/>
+          </a:p>
+        </p:txBody>
+      </p:sp>
+      <p:sp>
+        <p:nvSpPr>
+          <p:cNvPr id="190" name="Text 188"/>
+          <p:cNvSpPr txBox="1"/>
+          <p:nvPr/>
+        </p:nvSpPr>
+        <p:spPr>
+          <a:xfrm>
+            <a:off x="10602468" y="5879592"/>
+            <a:ext cx="946404" cy="155448"/>
+          </a:xfrm>
+          <a:prstGeom prst="rect">
+            <a:avLst/>
+          </a:prstGeom>
+          <a:noFill/>
+          <a:ln/>
+        </p:spPr>
+        <p:txBody>
+          <a:bodyPr wrap="square" lIns="0" tIns="0" rIns="0" bIns="0" rtlCol="0" anchor="ctr"/>
+          <a:lstStyle/>
+          <a:p>
+            <a:pPr algn="ctr" indent="0" marL="0">
+              <a:buNone/>
+            </a:pPr>
+            <a:r>
+              <a:rPr lang="en-US" sz="540" b="1" dirty="0">
+                <a:solidFill>
+                  <a:srgbClr val="C88A2E"/>
+                </a:solidFill>
+                <a:latin typeface="Poppins" pitchFamily="34" charset="0"/>
+                <a:ea typeface="Poppins" pitchFamily="34" charset="-122"/>
+                <a:cs typeface="Poppins" pitchFamily="34" charset="-120"/>
+              </a:rPr>
+              <a:t>PENDING EXTERNAL</a:t>
+            </a:r>
+            <a:endParaRPr lang="en-US" sz="540" dirty="0"/>
+          </a:p>
+        </p:txBody>
+      </p:sp>
+      <p:sp>
+        <p:nvSpPr>
+          <p:cNvPr id="191" name="Text 189"/>
+          <p:cNvSpPr txBox="1"/>
+          <p:nvPr/>
+        </p:nvSpPr>
+        <p:spPr>
+          <a:xfrm>
+            <a:off x="7379208" y="6099048"/>
+            <a:ext cx="4197096" cy="274320"/>
+          </a:xfrm>
+          <a:prstGeom prst="rect">
+            <a:avLst/>
+          </a:prstGeom>
+          <a:noFill/>
+          <a:ln/>
+        </p:spPr>
+        <p:txBody>
+          <a:bodyPr wrap="square" lIns="0" tIns="0" rIns="0" bIns="0" rtlCol="0" anchor="t"/>
+          <a:lstStyle/>
+          <a:p>
+            <a:pPr indent="0" marL="0">
+              <a:buNone/>
+            </a:pPr>
+            <a:r>
+              <a:rPr lang="en-US" sz="640" dirty="0">
+                <a:solidFill>
+                  <a:srgbClr val="5E7280"/>
+                </a:solidFill>
+                <a:latin typeface="Poppins" pitchFamily="34" charset="0"/>
+                <a:ea typeface="Poppins" pitchFamily="34" charset="-122"/>
+                <a:cs typeface="Poppins" pitchFamily="34" charset="-120"/>
+              </a:rPr>
+              <a:t>Pending Internal and Pending External are inside the 657 — 41 tickets, 6% of it; exclude both and the backlog reads 616. The number to watch is the other end: 529 of 657, 81%, have never left New.</a:t>
+            </a:r>
+            <a:endParaRPr lang="en-US" sz="640" dirty="0"/>
+          </a:p>
+        </p:txBody>
+      </p:sp>
+      <p:sp>
+        <p:nvSpPr>
+          <p:cNvPr id="192" name="Shape 190"/>
+          <p:cNvSpPr/>
+          <p:nvPr/>
+        </p:nvSpPr>
+        <p:spPr>
+          <a:xfrm>
             <a:off x="8642909" y="6510528"/>
             <a:ext cx="3134563" cy="256032"/>
           </a:xfrm>
@@ -53689,7 +54242,7 @@
       </p:sp>
       <p:sp>
         <p:nvSpPr>
-          <p:cNvPr id="176" name="Text 174"/>
+          <p:cNvPr id="193" name="Text 191"/>
           <p:cNvSpPr txBox="1"/>
           <p:nvPr/>
         </p:nvSpPr>

</xml_diff>